<commit_message>
Add presenter and date to title slide
Co-authored-by: 2831001962-coder <2831001962-coder@users.noreply.github.com>
</commit_message>
<xml_diff>
--- a/plan_presentation_5slides.pptx
+++ b/plan_presentation_5slides.pptx
@@ -3141,6 +3141,12 @@
           <a:p>
             <a:r>
               <a:t>Focus: Evaluation innovation only</a:t>
+            </a:r>
+          </a:p>
+          <a:p/>
+          <a:p>
+            <a:r>
+              <a:t>Presenter: Qingpeng    Date: 7.1</a:t>
             </a:r>
           </a:p>
         </p:txBody>

</xml_diff>